<commit_message>
fix(mobile): isolate desktop sidebar-collapsed rules to prevent mobile sidebar from appearing as a tiny strip
</commit_message>
<xml_diff>
--- a/ThermIQ_Submission_Deck.pptx
+++ b/ThermIQ_Submission_Deck.pptx
@@ -9070,8 +9070,8 @@
         </p:nvSpPr>
         <p:spPr>
           <a:xfrm>
-            <a:off x="502920" y="1463040"/>
-            <a:ext cx="3611880" cy="4846320"/>
+            <a:off x="502920" y="1444752"/>
+            <a:ext cx="3611880" cy="4160520"/>
           </a:xfrm>
           <a:prstGeom prst="roundRect">
             <a:avLst>
@@ -9097,8 +9097,8 @@
         </p:nvSpPr>
         <p:spPr>
           <a:xfrm>
-            <a:off x="704088" y="1627632"/>
-            <a:ext cx="3209544" cy="365760"/>
+            <a:off x="722376" y="1627632"/>
+            <a:ext cx="3172968" cy="365760"/>
           </a:xfrm>
           <a:prstGeom prst="rect">
             <a:avLst/>
@@ -9114,7 +9114,7 @@
               <a:buNone/>
             </a:pPr>
             <a:r>
-              <a:rPr lang="en-US" sz="1600" dirty="0">
+              <a:rPr lang="en-US" sz="1650" dirty="0">
                 <a:solidFill>
                   <a:srgbClr val="3F7A4A"/>
                 </a:solidFill>
@@ -9128,7 +9128,7 @@
               <a:buNone/>
             </a:pPr>
             <a:r>
-              <a:rPr lang="en-US" sz="1600" b="1" dirty="0">
+              <a:rPr lang="en-US" sz="1650" b="1" dirty="0">
                 <a:solidFill>
                   <a:srgbClr val="16283F"/>
                 </a:solidFill>
@@ -9138,7 +9138,7 @@
               </a:rPr>
               <a:t>Live today</a:t>
             </a:r>
-            <a:endParaRPr lang="en-US" sz="1600" dirty="0"/>
+            <a:endParaRPr lang="en-US" sz="1650" dirty="0"/>
           </a:p>
         </p:txBody>
       </p:sp>
@@ -9150,8 +9150,8 @@
         </p:nvSpPr>
         <p:spPr>
           <a:xfrm>
-            <a:off x="704088" y="2066544"/>
-            <a:ext cx="3209544" cy="0"/>
+            <a:off x="722376" y="2103120"/>
+            <a:ext cx="3172968" cy="0"/>
           </a:xfrm>
           <a:prstGeom prst="line">
             <a:avLst/>
@@ -9173,8 +9173,8 @@
         </p:nvSpPr>
         <p:spPr>
           <a:xfrm>
-            <a:off x="777240" y="2212848"/>
-            <a:ext cx="3154680" cy="3931920"/>
+            <a:off x="795528" y="2267712"/>
+            <a:ext cx="3099816" cy="3172968"/>
           </a:xfrm>
           <a:prstGeom prst="rect">
             <a:avLst/>
@@ -9186,18 +9186,18 @@
           <a:bodyPr wrap="square" rtlCol="0" anchor="t"/>
           <a:lstStyle/>
           <a:p>
-            <a:pPr marL="165100" indent="-165100">
+            <a:pPr marL="177800" indent="-177800">
               <a:lnSpc>
-                <a:spcPct val="98000"/>
+                <a:spcPct val="100000"/>
               </a:lnSpc>
               <a:spcAft>
-                <a:spcPts val="700"/>
+                <a:spcPts val="1100"/>
               </a:spcAft>
               <a:buSzPct val="100000"/>
               <a:buChar char="•"/>
             </a:pPr>
             <a:r>
-              <a:rPr lang="en-US" sz="1180" dirty="0">
+              <a:rPr lang="en-US" sz="1280" dirty="0">
                 <a:solidFill>
                   <a:srgbClr val="16283F"/>
                 </a:solidFill>
@@ -9207,21 +9207,21 @@
               </a:rPr>
               <a:t>Single-page app with five working views</a:t>
             </a:r>
-            <a:endParaRPr lang="en-US" sz="1180" dirty="0"/>
-          </a:p>
-          <a:p>
-            <a:pPr marL="165100" indent="-165100">
+            <a:endParaRPr lang="en-US" sz="1280" dirty="0"/>
+          </a:p>
+          <a:p>
+            <a:pPr marL="177800" indent="-177800">
               <a:lnSpc>
-                <a:spcPct val="98000"/>
+                <a:spcPct val="100000"/>
               </a:lnSpc>
               <a:spcAft>
-                <a:spcPts val="700"/>
+                <a:spcPts val="1100"/>
               </a:spcAft>
               <a:buSzPct val="100000"/>
               <a:buChar char="•"/>
             </a:pPr>
             <a:r>
-              <a:rPr lang="en-US" sz="1180" dirty="0">
+              <a:rPr lang="en-US" sz="1280" dirty="0">
                 <a:solidFill>
                   <a:srgbClr val="16283F"/>
                 </a:solidFill>
@@ -9231,21 +9231,21 @@
               </a:rPr>
               <a:t>RAG copilot with source citations</a:t>
             </a:r>
-            <a:endParaRPr lang="en-US" sz="1180" dirty="0"/>
-          </a:p>
-          <a:p>
-            <a:pPr marL="165100" indent="-165100">
+            <a:endParaRPr lang="en-US" sz="1280" dirty="0"/>
+          </a:p>
+          <a:p>
+            <a:pPr marL="177800" indent="-177800">
               <a:lnSpc>
-                <a:spcPct val="98000"/>
+                <a:spcPct val="100000"/>
               </a:lnSpc>
               <a:spcAft>
-                <a:spcPts val="700"/>
+                <a:spcPts val="1100"/>
               </a:spcAft>
               <a:buSzPct val="100000"/>
               <a:buChar char="•"/>
             </a:pPr>
             <a:r>
-              <a:rPr lang="en-US" sz="1180" dirty="0">
+              <a:rPr lang="en-US" sz="1280" dirty="0">
                 <a:solidFill>
                   <a:srgbClr val="16283F"/>
                 </a:solidFill>
@@ -9255,21 +9255,21 @@
               </a:rPr>
               <a:t>19-item gap-scoring engine (v3)</a:t>
             </a:r>
-            <a:endParaRPr lang="en-US" sz="1180" dirty="0"/>
-          </a:p>
-          <a:p>
-            <a:pPr marL="165100" indent="-165100">
+            <a:endParaRPr lang="en-US" sz="1280" dirty="0"/>
+          </a:p>
+          <a:p>
+            <a:pPr marL="177800" indent="-177800">
               <a:lnSpc>
-                <a:spcPct val="98000"/>
+                <a:spcPct val="100000"/>
               </a:lnSpc>
               <a:spcAft>
-                <a:spcPts val="700"/>
+                <a:spcPts val="1100"/>
               </a:spcAft>
               <a:buSzPct val="100000"/>
               <a:buChar char="•"/>
             </a:pPr>
             <a:r>
-              <a:rPr lang="en-US" sz="1180" dirty="0">
+              <a:rPr lang="en-US" sz="1280" dirty="0">
                 <a:solidFill>
                   <a:srgbClr val="16283F"/>
                 </a:solidFill>
@@ -9279,21 +9279,21 @@
               </a:rPr>
               <a:t>Rupee risk register, ranked &amp; exportable</a:t>
             </a:r>
-            <a:endParaRPr lang="en-US" sz="1180" dirty="0"/>
-          </a:p>
-          <a:p>
-            <a:pPr marL="165100" indent="-165100">
+            <a:endParaRPr lang="en-US" sz="1280" dirty="0"/>
+          </a:p>
+          <a:p>
+            <a:pPr marL="177800" indent="-177800">
               <a:lnSpc>
-                <a:spcPct val="98000"/>
+                <a:spcPct val="100000"/>
               </a:lnSpc>
               <a:spcAft>
-                <a:spcPts val="700"/>
+                <a:spcPts val="1100"/>
               </a:spcAft>
               <a:buSzPct val="100000"/>
               <a:buChar char="•"/>
             </a:pPr>
             <a:r>
-              <a:rPr lang="en-US" sz="1180" dirty="0">
+              <a:rPr lang="en-US" sz="1280" dirty="0">
                 <a:solidFill>
                   <a:srgbClr val="16283F"/>
                 </a:solidFill>
@@ -9303,21 +9303,21 @@
               </a:rPr>
               <a:t>Neo4j graph with click-through traversal</a:t>
             </a:r>
-            <a:endParaRPr lang="en-US" sz="1180" dirty="0"/>
-          </a:p>
-          <a:p>
-            <a:pPr marL="165100" indent="-165100">
+            <a:endParaRPr lang="en-US" sz="1280" dirty="0"/>
+          </a:p>
+          <a:p>
+            <a:pPr marL="177800" indent="-177800">
               <a:lnSpc>
-                <a:spcPct val="98000"/>
+                <a:spcPct val="100000"/>
               </a:lnSpc>
               <a:spcAft>
-                <a:spcPts val="700"/>
+                <a:spcPts val="1100"/>
               </a:spcAft>
               <a:buSzPct val="100000"/>
               <a:buChar char="•"/>
             </a:pPr>
             <a:r>
-              <a:rPr lang="en-US" sz="1180" dirty="0">
+              <a:rPr lang="en-US" sz="1280" dirty="0">
                 <a:solidFill>
                   <a:srgbClr val="16283F"/>
                 </a:solidFill>
@@ -9327,21 +9327,21 @@
               </a:rPr>
               <a:t>Per-plant profiles (NTPC, Saraighat)</a:t>
             </a:r>
-            <a:endParaRPr lang="en-US" sz="1180" dirty="0"/>
-          </a:p>
-          <a:p>
-            <a:pPr marL="165100" indent="-165100">
+            <a:endParaRPr lang="en-US" sz="1280" dirty="0"/>
+          </a:p>
+          <a:p>
+            <a:pPr marL="177800" indent="-177800">
               <a:lnSpc>
-                <a:spcPct val="98000"/>
+                <a:spcPct val="100000"/>
               </a:lnSpc>
               <a:spcAft>
-                <a:spcPts val="700"/>
+                <a:spcPts val="1100"/>
               </a:spcAft>
               <a:buSzPct val="100000"/>
               <a:buChar char="•"/>
             </a:pPr>
             <a:r>
-              <a:rPr lang="en-US" sz="1180" dirty="0">
+              <a:rPr lang="en-US" sz="1280" dirty="0">
                 <a:solidFill>
                   <a:srgbClr val="16283F"/>
                 </a:solidFill>
@@ -9351,7 +9351,7 @@
               </a:rPr>
               <a:t>Automated CEA-ingest &amp; gap-scan pipelines</a:t>
             </a:r>
-            <a:endParaRPr lang="en-US" sz="1180" dirty="0"/>
+            <a:endParaRPr lang="en-US" sz="1280" dirty="0"/>
           </a:p>
         </p:txBody>
       </p:sp>
@@ -9363,8 +9363,8 @@
         </p:nvSpPr>
         <p:spPr>
           <a:xfrm>
-            <a:off x="4288536" y="1463040"/>
-            <a:ext cx="3611880" cy="4846320"/>
+            <a:off x="4288536" y="1444752"/>
+            <a:ext cx="3611880" cy="4160520"/>
           </a:xfrm>
           <a:prstGeom prst="roundRect">
             <a:avLst>
@@ -9374,7 +9374,7 @@
           <a:solidFill>
             <a:srgbClr val="FFFFFF"/>
           </a:solidFill>
-          <a:ln w="15240">
+          <a:ln w="16510">
             <a:solidFill>
               <a:srgbClr val="D97A2B"/>
             </a:solidFill>
@@ -9390,8 +9390,8 @@
         </p:nvSpPr>
         <p:spPr>
           <a:xfrm>
-            <a:off x="4489704" y="1627632"/>
-            <a:ext cx="3209544" cy="365760"/>
+            <a:off x="4507992" y="1627632"/>
+            <a:ext cx="3172968" cy="365760"/>
           </a:xfrm>
           <a:prstGeom prst="rect">
             <a:avLst/>
@@ -9407,7 +9407,7 @@
               <a:buNone/>
             </a:pPr>
             <a:r>
-              <a:rPr lang="en-US" sz="1600" dirty="0">
+              <a:rPr lang="en-US" sz="1650" dirty="0">
                 <a:solidFill>
                   <a:srgbClr val="B0553A"/>
                 </a:solidFill>
@@ -9421,7 +9421,7 @@
               <a:buNone/>
             </a:pPr>
             <a:r>
-              <a:rPr lang="en-US" sz="1600" b="1" dirty="0">
+              <a:rPr lang="en-US" sz="1650" b="1" dirty="0">
                 <a:solidFill>
                   <a:srgbClr val="16283F"/>
                 </a:solidFill>
@@ -9431,7 +9431,7 @@
               </a:rPr>
               <a:t>Known limitations</a:t>
             </a:r>
-            <a:endParaRPr lang="en-US" sz="1600" dirty="0"/>
+            <a:endParaRPr lang="en-US" sz="1650" dirty="0"/>
           </a:p>
         </p:txBody>
       </p:sp>
@@ -9443,8 +9443,8 @@
         </p:nvSpPr>
         <p:spPr>
           <a:xfrm>
-            <a:off x="4489704" y="2066544"/>
-            <a:ext cx="3209544" cy="0"/>
+            <a:off x="4507992" y="2103120"/>
+            <a:ext cx="3172968" cy="0"/>
           </a:xfrm>
           <a:prstGeom prst="line">
             <a:avLst/>
@@ -9466,8 +9466,8 @@
         </p:nvSpPr>
         <p:spPr>
           <a:xfrm>
-            <a:off x="4562856" y="2212848"/>
-            <a:ext cx="3154680" cy="3931920"/>
+            <a:off x="4581144" y="2267712"/>
+            <a:ext cx="3099816" cy="3172968"/>
           </a:xfrm>
           <a:prstGeom prst="rect">
             <a:avLst/>
@@ -9479,18 +9479,18 @@
           <a:bodyPr wrap="square" rtlCol="0" anchor="t"/>
           <a:lstStyle/>
           <a:p>
-            <a:pPr marL="165100" indent="-165100">
+            <a:pPr marL="177800" indent="-177800">
               <a:lnSpc>
-                <a:spcPct val="98000"/>
+                <a:spcPct val="100000"/>
               </a:lnSpc>
               <a:spcAft>
-                <a:spcPts val="700"/>
+                <a:spcPts val="1100"/>
               </a:spcAft>
               <a:buSzPct val="100000"/>
               <a:buChar char="•"/>
             </a:pPr>
             <a:r>
-              <a:rPr lang="en-US" sz="1180" dirty="0">
+              <a:rPr lang="en-US" sz="1280" dirty="0">
                 <a:solidFill>
                   <a:srgbClr val="16283F"/>
                 </a:solidFill>
@@ -9500,21 +9500,21 @@
               </a:rPr>
               <a:t>One source spec (BMD-01) unreachable from the build network</a:t>
             </a:r>
-            <a:endParaRPr lang="en-US" sz="1180" dirty="0"/>
-          </a:p>
-          <a:p>
-            <a:pPr marL="165100" indent="-165100">
+            <a:endParaRPr lang="en-US" sz="1280" dirty="0"/>
+          </a:p>
+          <a:p>
+            <a:pPr marL="177800" indent="-177800">
               <a:lnSpc>
-                <a:spcPct val="98000"/>
+                <a:spcPct val="100000"/>
               </a:lnSpc>
               <a:spcAft>
-                <a:spcPts val="700"/>
+                <a:spcPts val="1100"/>
               </a:spcAft>
               <a:buSzPct val="100000"/>
               <a:buChar char="•"/>
             </a:pPr>
             <a:r>
-              <a:rPr lang="en-US" sz="1180" dirty="0">
+              <a:rPr lang="en-US" sz="1280" dirty="0">
                 <a:solidFill>
                   <a:srgbClr val="16283F"/>
                 </a:solidFill>
@@ -9524,21 +9524,21 @@
               </a:rPr>
               <a:t>No computer-vision P&amp;ID parsing yet — text + OCR only</a:t>
             </a:r>
-            <a:endParaRPr lang="en-US" sz="1180" dirty="0"/>
-          </a:p>
-          <a:p>
-            <a:pPr marL="165100" indent="-165100">
+            <a:endParaRPr lang="en-US" sz="1280" dirty="0"/>
+          </a:p>
+          <a:p>
+            <a:pPr marL="177800" indent="-177800">
               <a:lnSpc>
-                <a:spcPct val="98000"/>
+                <a:spcPct val="100000"/>
               </a:lnSpc>
               <a:spcAft>
-                <a:spcPts val="700"/>
+                <a:spcPts val="1100"/>
               </a:spcAft>
               <a:buSzPct val="100000"/>
               <a:buChar char="•"/>
             </a:pPr>
             <a:r>
-              <a:rPr lang="en-US" sz="1180" dirty="0">
+              <a:rPr lang="en-US" sz="1280" dirty="0">
                 <a:solidFill>
                   <a:srgbClr val="16283F"/>
                 </a:solidFill>
@@ -9548,21 +9548,21 @@
               </a:rPr>
               <a:t>Free-tier hosting caps backend functions</a:t>
             </a:r>
-            <a:endParaRPr lang="en-US" sz="1180" dirty="0"/>
-          </a:p>
-          <a:p>
-            <a:pPr marL="165100" indent="-165100">
+            <a:endParaRPr lang="en-US" sz="1280" dirty="0"/>
+          </a:p>
+          <a:p>
+            <a:pPr marL="177800" indent="-177800">
               <a:lnSpc>
-                <a:spcPct val="98000"/>
+                <a:spcPct val="100000"/>
               </a:lnSpc>
               <a:spcAft>
-                <a:spcPts val="700"/>
+                <a:spcPts val="1100"/>
               </a:spcAft>
               <a:buSzPct val="100000"/>
               <a:buChar char="•"/>
             </a:pPr>
             <a:r>
-              <a:rPr lang="en-US" sz="1180" dirty="0">
+              <a:rPr lang="en-US" sz="1280" dirty="0">
                 <a:solidFill>
                   <a:srgbClr val="16283F"/>
                 </a:solidFill>
@@ -9572,21 +9572,21 @@
               </a:rPr>
               <a:t>A finer v4 scoring engine is built but held back pending human review of two outliers</a:t>
             </a:r>
-            <a:endParaRPr lang="en-US" sz="1180" dirty="0"/>
-          </a:p>
-          <a:p>
-            <a:pPr marL="165100" indent="-165100">
+            <a:endParaRPr lang="en-US" sz="1280" dirty="0"/>
+          </a:p>
+          <a:p>
+            <a:pPr marL="177800" indent="-177800">
               <a:lnSpc>
-                <a:spcPct val="98000"/>
+                <a:spcPct val="100000"/>
               </a:lnSpc>
               <a:spcAft>
-                <a:spcPts val="700"/>
+                <a:spcPts val="1100"/>
               </a:spcAft>
               <a:buSzPct val="100000"/>
               <a:buChar char="•"/>
             </a:pPr>
             <a:r>
-              <a:rPr lang="en-US" sz="1180" dirty="0">
+              <a:rPr lang="en-US" sz="1280" dirty="0">
                 <a:solidFill>
                   <a:srgbClr val="16283F"/>
                 </a:solidFill>
@@ -9596,7 +9596,7 @@
               </a:rPr>
               <a:t>Accuracy not yet scored against a formal expert benchmark</a:t>
             </a:r>
-            <a:endParaRPr lang="en-US" sz="1180" dirty="0"/>
+            <a:endParaRPr lang="en-US" sz="1280" dirty="0"/>
           </a:p>
         </p:txBody>
       </p:sp>
@@ -9608,8 +9608,8 @@
         </p:nvSpPr>
         <p:spPr>
           <a:xfrm>
-            <a:off x="8074152" y="1463040"/>
-            <a:ext cx="3611880" cy="4846320"/>
+            <a:off x="8074152" y="1444752"/>
+            <a:ext cx="3611880" cy="4160520"/>
           </a:xfrm>
           <a:prstGeom prst="roundRect">
             <a:avLst>
@@ -9635,8 +9635,8 @@
         </p:nvSpPr>
         <p:spPr>
           <a:xfrm>
-            <a:off x="8275320" y="1627632"/>
-            <a:ext cx="3209544" cy="365760"/>
+            <a:off x="8293608" y="1627632"/>
+            <a:ext cx="3172968" cy="365760"/>
           </a:xfrm>
           <a:prstGeom prst="rect">
             <a:avLst/>
@@ -9652,7 +9652,7 @@
               <a:buNone/>
             </a:pPr>
             <a:r>
-              <a:rPr lang="en-US" sz="1600" dirty="0">
+              <a:rPr lang="en-US" sz="1650" dirty="0">
                 <a:solidFill>
                   <a:srgbClr val="D97A2B"/>
                 </a:solidFill>
@@ -9666,7 +9666,7 @@
               <a:buNone/>
             </a:pPr>
             <a:r>
-              <a:rPr lang="en-US" sz="1600" b="1" dirty="0">
+              <a:rPr lang="en-US" sz="1650" b="1" dirty="0">
                 <a:solidFill>
                   <a:srgbClr val="16283F"/>
                 </a:solidFill>
@@ -9676,7 +9676,7 @@
               </a:rPr>
               <a:t>Roadmap</a:t>
             </a:r>
-            <a:endParaRPr lang="en-US" sz="1600" dirty="0"/>
+            <a:endParaRPr lang="en-US" sz="1650" dirty="0"/>
           </a:p>
         </p:txBody>
       </p:sp>
@@ -9688,8 +9688,8 @@
         </p:nvSpPr>
         <p:spPr>
           <a:xfrm>
-            <a:off x="8275320" y="2066544"/>
-            <a:ext cx="3209544" cy="0"/>
+            <a:off x="8293608" y="2103120"/>
+            <a:ext cx="3172968" cy="0"/>
           </a:xfrm>
           <a:prstGeom prst="line">
             <a:avLst/>
@@ -9711,8 +9711,8 @@
         </p:nvSpPr>
         <p:spPr>
           <a:xfrm>
-            <a:off x="8348472" y="2212848"/>
-            <a:ext cx="3154680" cy="3931920"/>
+            <a:off x="8366760" y="2267712"/>
+            <a:ext cx="3099816" cy="3172968"/>
           </a:xfrm>
           <a:prstGeom prst="rect">
             <a:avLst/>
@@ -9724,18 +9724,18 @@
           <a:bodyPr wrap="square" rtlCol="0" anchor="t"/>
           <a:lstStyle/>
           <a:p>
-            <a:pPr marL="165100" indent="-165100">
+            <a:pPr marL="177800" indent="-177800">
               <a:lnSpc>
-                <a:spcPct val="98000"/>
+                <a:spcPct val="100000"/>
               </a:lnSpc>
               <a:spcAft>
-                <a:spcPts val="700"/>
+                <a:spcPts val="1100"/>
               </a:spcAft>
               <a:buSzPct val="100000"/>
               <a:buChar char="•"/>
             </a:pPr>
             <a:r>
-              <a:rPr lang="en-US" sz="1180" dirty="0">
+              <a:rPr lang="en-US" sz="1280" dirty="0">
                 <a:solidFill>
                   <a:srgbClr val="16283F"/>
                 </a:solidFill>
@@ -9745,21 +9745,21 @@
               </a:rPr>
               <a:t>Computer-vision parsing of P&amp;IDs and engineering drawings</a:t>
             </a:r>
-            <a:endParaRPr lang="en-US" sz="1180" dirty="0"/>
-          </a:p>
-          <a:p>
-            <a:pPr marL="165100" indent="-165100">
+            <a:endParaRPr lang="en-US" sz="1280" dirty="0"/>
+          </a:p>
+          <a:p>
+            <a:pPr marL="177800" indent="-177800">
               <a:lnSpc>
-                <a:spcPct val="98000"/>
+                <a:spcPct val="100000"/>
               </a:lnSpc>
               <a:spcAft>
-                <a:spcPts val="700"/>
+                <a:spcPts val="1100"/>
               </a:spcAft>
               <a:buSzPct val="100000"/>
               <a:buChar char="•"/>
             </a:pPr>
             <a:r>
-              <a:rPr lang="en-US" sz="1180" dirty="0">
+              <a:rPr lang="en-US" sz="1280" dirty="0">
                 <a:solidFill>
                   <a:srgbClr val="16283F"/>
                 </a:solidFill>
@@ -9769,21 +9769,21 @@
               </a:rPr>
               <a:t>More plants onboarded at full document depth</a:t>
             </a:r>
-            <a:endParaRPr lang="en-US" sz="1180" dirty="0"/>
-          </a:p>
-          <a:p>
-            <a:pPr marL="165100" indent="-165100">
+            <a:endParaRPr lang="en-US" sz="1280" dirty="0"/>
+          </a:p>
+          <a:p>
+            <a:pPr marL="177800" indent="-177800">
               <a:lnSpc>
-                <a:spcPct val="98000"/>
+                <a:spcPct val="100000"/>
               </a:lnSpc>
               <a:spcAft>
-                <a:spcPts val="700"/>
+                <a:spcPts val="1100"/>
               </a:spcAft>
               <a:buSzPct val="100000"/>
               <a:buChar char="•"/>
             </a:pPr>
             <a:r>
-              <a:rPr lang="en-US" sz="1180" dirty="0">
+              <a:rPr lang="en-US" sz="1280" dirty="0">
                 <a:solidFill>
                   <a:srgbClr val="16283F"/>
                 </a:solidFill>
@@ -9793,21 +9793,21 @@
               </a:rPr>
               <a:t>Mobile-first field-technician view</a:t>
             </a:r>
-            <a:endParaRPr lang="en-US" sz="1180" dirty="0"/>
-          </a:p>
-          <a:p>
-            <a:pPr marL="165100" indent="-165100">
+            <a:endParaRPr lang="en-US" sz="1280" dirty="0"/>
+          </a:p>
+          <a:p>
+            <a:pPr marL="177800" indent="-177800">
               <a:lnSpc>
-                <a:spcPct val="98000"/>
+                <a:spcPct val="100000"/>
               </a:lnSpc>
               <a:spcAft>
-                <a:spcPts val="700"/>
+                <a:spcPts val="1100"/>
               </a:spcAft>
               <a:buSzPct val="100000"/>
               <a:buChar char="•"/>
             </a:pPr>
             <a:r>
-              <a:rPr lang="en-US" sz="1180" dirty="0">
+              <a:rPr lang="en-US" sz="1280" dirty="0">
                 <a:solidFill>
                   <a:srgbClr val="16283F"/>
                 </a:solidFill>
@@ -9817,21 +9817,21 @@
               </a:rPr>
               <a:t>Validated v4 evidence-graded scoring engine</a:t>
             </a:r>
-            <a:endParaRPr lang="en-US" sz="1180" dirty="0"/>
-          </a:p>
-          <a:p>
-            <a:pPr marL="165100" indent="-165100">
+            <a:endParaRPr lang="en-US" sz="1280" dirty="0"/>
+          </a:p>
+          <a:p>
+            <a:pPr marL="177800" indent="-177800">
               <a:lnSpc>
-                <a:spcPct val="98000"/>
+                <a:spcPct val="100000"/>
               </a:lnSpc>
               <a:spcAft>
-                <a:spcPts val="700"/>
+                <a:spcPts val="1100"/>
               </a:spcAft>
               <a:buSzPct val="100000"/>
               <a:buChar char="•"/>
             </a:pPr>
             <a:r>
-              <a:rPr lang="en-US" sz="1180" dirty="0">
+              <a:rPr lang="en-US" sz="1280" dirty="0">
                 <a:solidFill>
                   <a:srgbClr val="16283F"/>
                 </a:solidFill>
@@ -9841,13 +9841,93 @@
               </a:rPr>
               <a:t>Expert-benchmarked answer &amp; extraction accuracy</a:t>
             </a:r>
-            <a:endParaRPr lang="en-US" sz="1180" dirty="0"/>
-          </a:p>
-        </p:txBody>
-      </p:sp>
-      <p:sp>
-        <p:nvSpPr>
-          <p:cNvPr id="18" name="Text 16"/>
+            <a:endParaRPr lang="en-US" sz="1280" dirty="0"/>
+          </a:p>
+        </p:txBody>
+      </p:sp>
+      <p:sp>
+        <p:nvSpPr>
+          <p:cNvPr id="18" name="Shape 16"/>
+          <p:cNvSpPr/>
+          <p:nvPr/>
+        </p:nvSpPr>
+        <p:spPr>
+          <a:xfrm>
+            <a:off x="502920" y="5779008"/>
+            <a:ext cx="11183112" cy="694944"/>
+          </a:xfrm>
+          <a:prstGeom prst="roundRect">
+            <a:avLst>
+              <a:gd name="adj" fmla="val 7895"/>
+            </a:avLst>
+          </a:prstGeom>
+          <a:solidFill>
+            <a:srgbClr val="FBF1E7"/>
+          </a:solidFill>
+          <a:ln w="12700">
+            <a:solidFill>
+              <a:srgbClr val="D97A2B"/>
+            </a:solidFill>
+            <a:prstDash val="solid"/>
+          </a:ln>
+        </p:spPr>
+      </p:sp>
+      <p:sp>
+        <p:nvSpPr>
+          <p:cNvPr id="19" name="Text 17"/>
+          <p:cNvSpPr/>
+          <p:nvPr/>
+        </p:nvSpPr>
+        <p:spPr>
+          <a:xfrm>
+            <a:off x="713232" y="5779008"/>
+            <a:ext cx="10789920" cy="694944"/>
+          </a:xfrm>
+          <a:prstGeom prst="rect">
+            <a:avLst/>
+          </a:prstGeom>
+          <a:noFill/>
+          <a:ln/>
+        </p:spPr>
+        <p:txBody>
+          <a:bodyPr wrap="square" rtlCol="0" anchor="ctr"/>
+          <a:lstStyle/>
+          <a:p>
+            <a:pPr indent="0" marL="0">
+              <a:buNone/>
+            </a:pPr>
+            <a:r>
+              <a:rPr lang="en-US" sz="1250" b="1" dirty="0">
+                <a:solidFill>
+                  <a:srgbClr val="D97A2B"/>
+                </a:solidFill>
+                <a:latin typeface="Calibri" pitchFamily="34" charset="0"/>
+                <a:ea typeface="Calibri" pitchFamily="34" charset="-122"/>
+                <a:cs typeface="Calibri" pitchFamily="34" charset="-120"/>
+              </a:rPr>
+              <a:t>Shipped and honest:  </a:t>
+            </a:r>
+            <a:pPr indent="0" marL="0">
+              <a:buNone/>
+            </a:pPr>
+            <a:r>
+              <a:rPr lang="en-US" sz="1250" dirty="0">
+                <a:solidFill>
+                  <a:srgbClr val="16283F"/>
+                </a:solidFill>
+                <a:latin typeface="Calibri" pitchFamily="34" charset="0"/>
+                <a:ea typeface="Calibri" pitchFamily="34" charset="-122"/>
+                <a:cs typeface="Calibri" pitchFamily="34" charset="-120"/>
+              </a:rPr>
+              <a:t>v3 is the validated scoring engine running live today. The finer v4 engine and computer-vision drawing parsing are the immediate next milestones — deliberately not overstated as done.</a:t>
+            </a:r>
+            <a:endParaRPr lang="en-US" sz="1250" dirty="0"/>
+          </a:p>
+        </p:txBody>
+      </p:sp>
+      <p:sp>
+        <p:nvSpPr>
+          <p:cNvPr id="20" name="Text 18"/>
           <p:cNvSpPr/>
           <p:nvPr/>
         </p:nvSpPr>

</xml_diff>